<commit_message>
feat: présentation sans émojis + version PDF
- Suppression de tous les émojis de la présentation
- Ajout de la version PDF (24 pages, 111 Ko)
- Présentation prête pour la soutenance

Co-authored-by: DOCK221 <DOCK221@users.noreply.github.com>
</commit_message>
<xml_diff>
--- a/Soutenance_Mouhamadou_Sow_B3_CDI.pptx
+++ b/Soutenance_Mouhamadou_Sow_B3_CDI.pptx
@@ -3447,97 +3447,97 @@
               </a:defRPr>
             </a:pPr>
             <a:r>
-              <a:t>👤 Nom : Ouweik Chrystelle (pseudonyme : Ayaa.lbns)</a:t>
-            </a:r>
-          </a:p>
-          <a:p>
-            <a:pPr>
-              <a:spcAft>
-                <a:spcPts val="1200"/>
-              </a:spcAft>
-              <a:defRPr sz="1800">
-                <a:solidFill>
-                  <a:srgbClr val="333333"/>
-                </a:solidFill>
-              </a:defRPr>
-            </a:pPr>
-            <a:r>
-              <a:t>❤️ Engagement social : Aide aux personnes sans abri (France et international)</a:t>
-            </a:r>
-          </a:p>
-          <a:p>
-            <a:pPr>
-              <a:spcAft>
-                <a:spcPts val="1200"/>
-              </a:spcAft>
-              <a:defRPr sz="1800">
-                <a:solidFill>
-                  <a:srgbClr val="333333"/>
-                </a:solidFill>
-              </a:defRPr>
-            </a:pPr>
-            <a:r>
-              <a:t>🏠 Actions : Rénovation d'habitats, distribution de nourriture</a:t>
-            </a:r>
-          </a:p>
-          <a:p>
-            <a:pPr>
-              <a:spcAft>
-                <a:spcPts val="1200"/>
-              </a:spcAft>
-              <a:defRPr sz="1800">
-                <a:solidFill>
-                  <a:srgbClr val="333333"/>
-                </a:solidFill>
-              </a:defRPr>
-            </a:pPr>
-            <a:r>
-              <a:t>🌙 Visibilité accrue durant le Ramadan : ruptures du jeûne collectives</a:t>
-            </a:r>
-          </a:p>
-          <a:p>
-            <a:pPr>
-              <a:spcAft>
-                <a:spcPts val="1200"/>
-              </a:spcAft>
-              <a:defRPr sz="1800">
-                <a:solidFill>
-                  <a:srgbClr val="333333"/>
-                </a:solidFill>
-              </a:defRPr>
-            </a:pPr>
-            <a:r>
-              <a:t>👥 Impact : Réunit familles, entrepreneurs et personnes en difficulté</a:t>
-            </a:r>
-          </a:p>
-          <a:p>
-            <a:pPr>
-              <a:spcAft>
-                <a:spcPts val="1200"/>
-              </a:spcAft>
-              <a:defRPr sz="1800">
-                <a:solidFill>
-                  <a:srgbClr val="333333"/>
-                </a:solidFill>
-              </a:defRPr>
-            </a:pPr>
-            <a:r>
-              <a:t>✨ Image de marque : Authentique, engagée, humaine</a:t>
-            </a:r>
-          </a:p>
-          <a:p>
-            <a:pPr>
-              <a:spcAft>
-                <a:spcPts val="1200"/>
-              </a:spcAft>
-              <a:defRPr sz="1800">
-                <a:solidFill>
-                  <a:srgbClr val="333333"/>
-                </a:solidFill>
-              </a:defRPr>
-            </a:pPr>
-            <a:r>
-              <a:t>🤝 Adéquation : Valeurs de proximité alignées avec Buroxia</a:t>
+              <a:t>Nom : Ouweik Chrystelle (pseudonyme : Ayaa.lbns)</a:t>
+            </a:r>
+          </a:p>
+          <a:p>
+            <a:pPr>
+              <a:spcAft>
+                <a:spcPts val="1200"/>
+              </a:spcAft>
+              <a:defRPr sz="1800">
+                <a:solidFill>
+                  <a:srgbClr val="333333"/>
+                </a:solidFill>
+              </a:defRPr>
+            </a:pPr>
+            <a:r>
+              <a:t>Engagement social : Aide aux personnes sans abri (France et international)</a:t>
+            </a:r>
+          </a:p>
+          <a:p>
+            <a:pPr>
+              <a:spcAft>
+                <a:spcPts val="1200"/>
+              </a:spcAft>
+              <a:defRPr sz="1800">
+                <a:solidFill>
+                  <a:srgbClr val="333333"/>
+                </a:solidFill>
+              </a:defRPr>
+            </a:pPr>
+            <a:r>
+              <a:t>Actions : Rénovation d'habitats, distribution de nourriture</a:t>
+            </a:r>
+          </a:p>
+          <a:p>
+            <a:pPr>
+              <a:spcAft>
+                <a:spcPts val="1200"/>
+              </a:spcAft>
+              <a:defRPr sz="1800">
+                <a:solidFill>
+                  <a:srgbClr val="333333"/>
+                </a:solidFill>
+              </a:defRPr>
+            </a:pPr>
+            <a:r>
+              <a:t>Visibilité accrue durant le Ramadan : ruptures du jeûne collectives</a:t>
+            </a:r>
+          </a:p>
+          <a:p>
+            <a:pPr>
+              <a:spcAft>
+                <a:spcPts val="1200"/>
+              </a:spcAft>
+              <a:defRPr sz="1800">
+                <a:solidFill>
+                  <a:srgbClr val="333333"/>
+                </a:solidFill>
+              </a:defRPr>
+            </a:pPr>
+            <a:r>
+              <a:t>Impact : Réunit familles, entrepreneurs et personnes en difficulté</a:t>
+            </a:r>
+          </a:p>
+          <a:p>
+            <a:pPr>
+              <a:spcAft>
+                <a:spcPts val="1200"/>
+              </a:spcAft>
+              <a:defRPr sz="1800">
+                <a:solidFill>
+                  <a:srgbClr val="333333"/>
+                </a:solidFill>
+              </a:defRPr>
+            </a:pPr>
+            <a:r>
+              <a:t>Image de marque : Authentique, engagée, humaine</a:t>
+            </a:r>
+          </a:p>
+          <a:p>
+            <a:pPr>
+              <a:spcAft>
+                <a:spcPts val="1200"/>
+              </a:spcAft>
+              <a:defRPr sz="1800">
+                <a:solidFill>
+                  <a:srgbClr val="333333"/>
+                </a:solidFill>
+              </a:defRPr>
+            </a:pPr>
+            <a:r>
+              <a:t>Adéquation : Valeurs de proximité alignées avec Buroxia</a:t>
             </a:r>
           </a:p>
         </p:txBody>
@@ -3753,7 +3753,7 @@
               </a:defRPr>
             </a:pPr>
             <a:r>
-              <a:t>📱 Ayaa.lbns publie une story : recherche d'un bureau à Marseille pour 1 mois</a:t>
+              <a:t>Ayaa.lbns publie une story : recherche d'un bureau à Marseille pour 1 mois</a:t>
             </a:r>
           </a:p>
           <a:p>
@@ -3768,7 +3768,7 @@
               </a:defRPr>
             </a:pPr>
             <a:r>
-              <a:t>💡 Correspondance parfaite avec l'offre de Buroxia !</a:t>
+              <a:t>Correspondance parfaite avec l'offre de Buroxia</a:t>
             </a:r>
           </a:p>
           <a:p>
@@ -3783,7 +3783,7 @@
               </a:defRPr>
             </a:pPr>
             <a:r>
-              <a:t>📧 Contact immédiat avec le manager via l'e-mail indiqué</a:t>
+              <a:t>Contact immédiat avec le manager via l'e-mail indiqué</a:t>
             </a:r>
           </a:p>
           <a:p>
@@ -3798,7 +3798,7 @@
               </a:defRPr>
             </a:pPr>
             <a:r>
-              <a:t>⏰ Timing idéal pour proposer une collaboration structurée</a:t>
+              <a:t>Timing idéal pour proposer une collaboration structurée</a:t>
             </a:r>
           </a:p>
         </p:txBody>
@@ -3979,67 +3979,67 @@
               </a:defRPr>
             </a:pPr>
             <a:r>
-              <a:t>📧 E-mail professionnel rédigé au manager d'Ayaa.lbns</a:t>
-            </a:r>
-          </a:p>
-          <a:p>
-            <a:pPr>
-              <a:spcAft>
-                <a:spcPts val="1200"/>
-              </a:spcAft>
-              <a:defRPr sz="1800">
-                <a:solidFill>
-                  <a:srgbClr val="333333"/>
-                </a:solidFill>
-              </a:defRPr>
-            </a:pPr>
-            <a:r>
-              <a:t>🏢 Présentation de Buroxia et de ses services</a:t>
-            </a:r>
-          </a:p>
-          <a:p>
-            <a:pPr>
-              <a:spcAft>
-                <a:spcPts val="1200"/>
-              </a:spcAft>
-              <a:defRPr sz="1800">
-                <a:solidFill>
-                  <a:srgbClr val="333333"/>
-                </a:solidFill>
-              </a:defRPr>
-            </a:pPr>
-            <a:r>
-              <a:t>💼 Exposition claire des solutions (domiciliation, bureaux, coworking)</a:t>
-            </a:r>
-          </a:p>
-          <a:p>
-            <a:pPr>
-              <a:spcAft>
-                <a:spcPts val="1200"/>
-              </a:spcAft>
-              <a:defRPr sz="1800">
-                <a:solidFill>
-                  <a:srgbClr val="333333"/>
-                </a:solidFill>
-              </a:defRPr>
-            </a:pPr>
-            <a:r>
-              <a:t>🤝 Ouverture vers un partenariat incluant de la visibilité</a:t>
-            </a:r>
-          </a:p>
-          <a:p>
-            <a:pPr>
-              <a:spcAft>
-                <a:spcPts val="1200"/>
-              </a:spcAft>
-              <a:defRPr sz="1800">
-                <a:solidFill>
-                  <a:srgbClr val="333333"/>
-                </a:solidFill>
-              </a:defRPr>
-            </a:pPr>
-            <a:r>
-              <a:t>✅ Résultat : Contact favorable, échange approfondi engagé</a:t>
+              <a:t>E-mail professionnel rédigé au manager d'Ayaa.lbns</a:t>
+            </a:r>
+          </a:p>
+          <a:p>
+            <a:pPr>
+              <a:spcAft>
+                <a:spcPts val="1200"/>
+              </a:spcAft>
+              <a:defRPr sz="1800">
+                <a:solidFill>
+                  <a:srgbClr val="333333"/>
+                </a:solidFill>
+              </a:defRPr>
+            </a:pPr>
+            <a:r>
+              <a:t>Présentation de Buroxia et de ses services</a:t>
+            </a:r>
+          </a:p>
+          <a:p>
+            <a:pPr>
+              <a:spcAft>
+                <a:spcPts val="1200"/>
+              </a:spcAft>
+              <a:defRPr sz="1800">
+                <a:solidFill>
+                  <a:srgbClr val="333333"/>
+                </a:solidFill>
+              </a:defRPr>
+            </a:pPr>
+            <a:r>
+              <a:t>Exposition claire des solutions (domiciliation, bureaux, coworking)</a:t>
+            </a:r>
+          </a:p>
+          <a:p>
+            <a:pPr>
+              <a:spcAft>
+                <a:spcPts val="1200"/>
+              </a:spcAft>
+              <a:defRPr sz="1800">
+                <a:solidFill>
+                  <a:srgbClr val="333333"/>
+                </a:solidFill>
+              </a:defRPr>
+            </a:pPr>
+            <a:r>
+              <a:t>Ouverture vers un partenariat incluant de la visibilité</a:t>
+            </a:r>
+          </a:p>
+          <a:p>
+            <a:pPr>
+              <a:spcAft>
+                <a:spcPts val="1200"/>
+              </a:spcAft>
+              <a:defRPr sz="1800">
+                <a:solidFill>
+                  <a:srgbClr val="333333"/>
+                </a:solidFill>
+              </a:defRPr>
+            </a:pPr>
+            <a:r>
+              <a:t>Résultat : Contact favorable, échange approfondi engagé</a:t>
             </a:r>
           </a:p>
         </p:txBody>
@@ -4220,82 +4220,82 @@
               </a:defRPr>
             </a:pPr>
             <a:r>
-              <a:t>📄 Fiche de prestations de services complète</a:t>
-            </a:r>
-          </a:p>
-          <a:p>
-            <a:pPr>
-              <a:spcAft>
-                <a:spcPts val="1200"/>
-              </a:spcAft>
-              <a:defRPr sz="1800">
-                <a:solidFill>
-                  <a:srgbClr val="333333"/>
-                </a:solidFill>
-              </a:defRPr>
-            </a:pPr>
-            <a:r>
-              <a:t>💰 Grille tarifaire détaillée (formules, promotions, conditions)</a:t>
-            </a:r>
-          </a:p>
-          <a:p>
-            <a:pPr>
-              <a:spcAft>
-                <a:spcPts val="1200"/>
-              </a:spcAft>
-              <a:defRPr sz="1800">
-                <a:solidFill>
-                  <a:srgbClr val="333333"/>
-                </a:solidFill>
-              </a:defRPr>
-            </a:pPr>
-            <a:r>
-              <a:t>🎨 Design professionnel et cohérent (Canva)</a:t>
-            </a:r>
-          </a:p>
-          <a:p>
-            <a:pPr>
-              <a:spcAft>
-                <a:spcPts val="1200"/>
-              </a:spcAft>
-              <a:defRPr sz="1800">
-                <a:solidFill>
-                  <a:srgbClr val="333333"/>
-                </a:solidFill>
-              </a:defRPr>
-            </a:pPr>
-            <a:r>
-              <a:t>💼 Utilisation : Base de négociation et présentations</a:t>
-            </a:r>
-          </a:p>
-          <a:p>
-            <a:pPr>
-              <a:spcAft>
-                <a:spcPts val="1200"/>
-              </a:spcAft>
-              <a:defRPr sz="1800">
-                <a:solidFill>
-                  <a:srgbClr val="333333"/>
-                </a:solidFill>
-              </a:defRPr>
-            </a:pPr>
-            <a:r>
-              <a:t>♻️ Réutilisation : Supports pour la prospection commerciale générale</a:t>
-            </a:r>
-          </a:p>
-          <a:p>
-            <a:pPr>
-              <a:spcAft>
-                <a:spcPts val="1200"/>
-              </a:spcAft>
-              <a:defRPr sz="1800">
-                <a:solidFill>
-                  <a:srgbClr val="333333"/>
-                </a:solidFill>
-              </a:defRPr>
-            </a:pPr>
-            <a:r>
-              <a:t>✅ Impact : Renforcement du sérieux de la proposition</a:t>
+              <a:t>Fiche de prestations de services complète</a:t>
+            </a:r>
+          </a:p>
+          <a:p>
+            <a:pPr>
+              <a:spcAft>
+                <a:spcPts val="1200"/>
+              </a:spcAft>
+              <a:defRPr sz="1800">
+                <a:solidFill>
+                  <a:srgbClr val="333333"/>
+                </a:solidFill>
+              </a:defRPr>
+            </a:pPr>
+            <a:r>
+              <a:t>Grille tarifaire détaillée (formules, promotions, conditions)</a:t>
+            </a:r>
+          </a:p>
+          <a:p>
+            <a:pPr>
+              <a:spcAft>
+                <a:spcPts val="1200"/>
+              </a:spcAft>
+              <a:defRPr sz="1800">
+                <a:solidFill>
+                  <a:srgbClr val="333333"/>
+                </a:solidFill>
+              </a:defRPr>
+            </a:pPr>
+            <a:r>
+              <a:t>Design professionnel et cohérent (Canva)</a:t>
+            </a:r>
+          </a:p>
+          <a:p>
+            <a:pPr>
+              <a:spcAft>
+                <a:spcPts val="1200"/>
+              </a:spcAft>
+              <a:defRPr sz="1800">
+                <a:solidFill>
+                  <a:srgbClr val="333333"/>
+                </a:solidFill>
+              </a:defRPr>
+            </a:pPr>
+            <a:r>
+              <a:t>Utilisation : Base de négociation et présentations</a:t>
+            </a:r>
+          </a:p>
+          <a:p>
+            <a:pPr>
+              <a:spcAft>
+                <a:spcPts val="1200"/>
+              </a:spcAft>
+              <a:defRPr sz="1800">
+                <a:solidFill>
+                  <a:srgbClr val="333333"/>
+                </a:solidFill>
+              </a:defRPr>
+            </a:pPr>
+            <a:r>
+              <a:t>Réutilisation : Supports pour la prospection commerciale générale</a:t>
+            </a:r>
+          </a:p>
+          <a:p>
+            <a:pPr>
+              <a:spcAft>
+                <a:spcPts val="1200"/>
+              </a:spcAft>
+              <a:defRPr sz="1800">
+                <a:solidFill>
+                  <a:srgbClr val="333333"/>
+                </a:solidFill>
+              </a:defRPr>
+            </a:pPr>
+            <a:r>
+              <a:t>Impact : Renforcement du sérieux de la proposition</a:t>
             </a:r>
           </a:p>
         </p:txBody>
@@ -4476,82 +4476,82 @@
               </a:defRPr>
             </a:pPr>
             <a:r>
-              <a:t>🗓️ 3 réunions entre Buroxia et l'équipe d'Ayaa.lbns</a:t>
-            </a:r>
-          </a:p>
-          <a:p>
-            <a:pPr>
-              <a:spcAft>
-                <a:spcPts val="1200"/>
-              </a:spcAft>
-              <a:defRPr sz="1800">
-                <a:solidFill>
-                  <a:srgbClr val="333333"/>
-                </a:solidFill>
-              </a:defRPr>
-            </a:pPr>
-            <a:r>
-              <a:t>1️⃣ Réunion 1 (visio) : Présentation de l'offre et premiers échanges</a:t>
-            </a:r>
-          </a:p>
-          <a:p>
-            <a:pPr>
-              <a:spcAft>
-                <a:spcPts val="1200"/>
-              </a:spcAft>
-              <a:defRPr sz="1800">
-                <a:solidFill>
-                  <a:srgbClr val="333333"/>
-                </a:solidFill>
-              </a:defRPr>
-            </a:pPr>
-            <a:r>
-              <a:t>2️⃣ Réunion 2 (visio) : Affinage de la proposition et conditions</a:t>
-            </a:r>
-          </a:p>
-          <a:p>
-            <a:pPr>
-              <a:spcAft>
-                <a:spcPts val="1200"/>
-              </a:spcAft>
-              <a:defRPr sz="1800">
-                <a:solidFill>
-                  <a:srgbClr val="333333"/>
-                </a:solidFill>
-              </a:defRPr>
-            </a:pPr>
-            <a:r>
-              <a:t>3️⃣ Réunion 3 (présentiel) : Visite des locaux à Marseille + finalisation</a:t>
-            </a:r>
-          </a:p>
-          <a:p>
-            <a:pPr>
-              <a:spcAft>
-                <a:spcPts val="1200"/>
-              </a:spcAft>
-              <a:defRPr sz="1800">
-                <a:solidFill>
-                  <a:srgbClr val="333333"/>
-                </a:solidFill>
-              </a:defRPr>
-            </a:pPr>
-            <a:r>
-              <a:t>👥 Interlocuteurs : Direction Buroxia, Ayaa.lbns, son manager (Paris)</a:t>
-            </a:r>
-          </a:p>
-          <a:p>
-            <a:pPr>
-              <a:spcAft>
-                <a:spcPts val="1200"/>
-              </a:spcAft>
-              <a:defRPr sz="1800">
-                <a:solidFill>
-                  <a:srgbClr val="333333"/>
-                </a:solidFill>
-              </a:defRPr>
-            </a:pPr>
-            <a:r>
-              <a:t>📋 Mon rôle : Préparation des supports, participation active, suivi</a:t>
+              <a:t>3 réunions entre Buroxia et l'équipe d'Ayaa.lbns</a:t>
+            </a:r>
+          </a:p>
+          <a:p>
+            <a:pPr>
+              <a:spcAft>
+                <a:spcPts val="1200"/>
+              </a:spcAft>
+              <a:defRPr sz="1800">
+                <a:solidFill>
+                  <a:srgbClr val="333333"/>
+                </a:solidFill>
+              </a:defRPr>
+            </a:pPr>
+            <a:r>
+              <a:t>Réunion 1 (visio) : Présentation de l'offre et premiers échanges</a:t>
+            </a:r>
+          </a:p>
+          <a:p>
+            <a:pPr>
+              <a:spcAft>
+                <a:spcPts val="1200"/>
+              </a:spcAft>
+              <a:defRPr sz="1800">
+                <a:solidFill>
+                  <a:srgbClr val="333333"/>
+                </a:solidFill>
+              </a:defRPr>
+            </a:pPr>
+            <a:r>
+              <a:t>Réunion 2 (visio) : Affinage de la proposition et conditions</a:t>
+            </a:r>
+          </a:p>
+          <a:p>
+            <a:pPr>
+              <a:spcAft>
+                <a:spcPts val="1200"/>
+              </a:spcAft>
+              <a:defRPr sz="1800">
+                <a:solidFill>
+                  <a:srgbClr val="333333"/>
+                </a:solidFill>
+              </a:defRPr>
+            </a:pPr>
+            <a:r>
+              <a:t>Réunion 3 (présentiel) : Visite des locaux à Marseille + finalisation</a:t>
+            </a:r>
+          </a:p>
+          <a:p>
+            <a:pPr>
+              <a:spcAft>
+                <a:spcPts val="1200"/>
+              </a:spcAft>
+              <a:defRPr sz="1800">
+                <a:solidFill>
+                  <a:srgbClr val="333333"/>
+                </a:solidFill>
+              </a:defRPr>
+            </a:pPr>
+            <a:r>
+              <a:t>Interlocuteurs : Direction Buroxia, Ayaa.lbns, son manager (Paris)</a:t>
+            </a:r>
+          </a:p>
+          <a:p>
+            <a:pPr>
+              <a:spcAft>
+                <a:spcPts val="1200"/>
+              </a:spcAft>
+              <a:defRPr sz="1800">
+                <a:solidFill>
+                  <a:srgbClr val="333333"/>
+                </a:solidFill>
+              </a:defRPr>
+            </a:pPr>
+            <a:r>
+              <a:t>Mon rôle : Préparation des supports, participation active, suivi</a:t>
             </a:r>
           </a:p>
         </p:txBody>
@@ -4767,7 +4767,7 @@
               </a:defRPr>
             </a:pPr>
             <a:r>
-              <a:t>💡 Clause spécifique : 50% prix location + 50% contrepartie publicitaire</a:t>
+              <a:t>Clause spécifique : 50% prix location + 50% contrepartie publicitaire</a:t>
             </a:r>
           </a:p>
           <a:p>
@@ -4782,7 +4782,7 @@
               </a:defRPr>
             </a:pPr>
             <a:r>
-              <a:t>🏢 Pour Buroxia : Visibilité auprès d'une audience qualifiée</a:t>
+              <a:t>Pour Buroxia : Visibilité auprès d'une audience qualifiée</a:t>
             </a:r>
           </a:p>
           <a:p>
@@ -4797,7 +4797,7 @@
               </a:defRPr>
             </a:pPr>
             <a:r>
-              <a:t>👤 Pour Ayaa.lbns : Espace professionnel à conditions avantageuses</a:t>
+              <a:t>Pour Ayaa.lbns : Espace professionnel à conditions avantageuses</a:t>
             </a:r>
           </a:p>
           <a:p>
@@ -4812,7 +4812,7 @@
               </a:defRPr>
             </a:pPr>
             <a:r>
-              <a:t>✅ Résultat : Signature du contrat dans les locaux de Buroxia à Marseille</a:t>
+              <a:t>Résultat : Signature du contrat dans les locaux de Buroxia à Marseille</a:t>
             </a:r>
           </a:p>
         </p:txBody>
@@ -4993,82 +4993,82 @@
               </a:defRPr>
             </a:pPr>
             <a:r>
-              <a:t>✅ Signature d'une collaboration avec Ayaa.lbns</a:t>
-            </a:r>
-          </a:p>
-          <a:p>
-            <a:pPr>
-              <a:spcAft>
-                <a:spcPts val="1200"/>
-              </a:spcAft>
-              <a:defRPr sz="1800">
-                <a:solidFill>
-                  <a:srgbClr val="333333"/>
-                </a:solidFill>
-              </a:defRPr>
-            </a:pPr>
-            <a:r>
-              <a:t>📈 Exposition de Buroxia auprès de l'audience de l'influenceuse</a:t>
-            </a:r>
-          </a:p>
-          <a:p>
-            <a:pPr>
-              <a:spcAft>
-                <a:spcPts val="1200"/>
-              </a:spcAft>
-              <a:defRPr sz="1800">
-                <a:solidFill>
-                  <a:srgbClr val="333333"/>
-                </a:solidFill>
-              </a:defRPr>
-            </a:pPr>
-            <a:r>
-              <a:t>🏆 Association à une créatrice reconnue pour son engagement social</a:t>
-            </a:r>
-          </a:p>
-          <a:p>
-            <a:pPr>
-              <a:spcAft>
-                <a:spcPts val="1200"/>
-              </a:spcAft>
-              <a:defRPr sz="1800">
-                <a:solidFill>
-                  <a:srgbClr val="333333"/>
-                </a:solidFill>
-              </a:defRPr>
-            </a:pPr>
-            <a:r>
-              <a:t>📄 Livrables : Fiche de prestations, grille tarifaire, contrat signé</a:t>
-            </a:r>
-          </a:p>
-          <a:p>
-            <a:pPr>
-              <a:spcAft>
-                <a:spcPts val="1200"/>
-              </a:spcAft>
-              <a:defRPr sz="1800">
-                <a:solidFill>
-                  <a:srgbClr val="333333"/>
-                </a:solidFill>
-              </a:defRPr>
-            </a:pPr>
-            <a:r>
-              <a:t>🏢 Occupation : Mise à disposition d'un bureau pour 1 mois</a:t>
-            </a:r>
-          </a:p>
-          <a:p>
-            <a:pPr>
-              <a:spcAft>
-                <a:spcPts val="1200"/>
-              </a:spcAft>
-              <a:defRPr sz="1800">
-                <a:solidFill>
-                  <a:srgbClr val="333333"/>
-                </a:solidFill>
-              </a:defRPr>
-            </a:pPr>
-            <a:r>
-              <a:t>🚀 Impact : Premier partenariat influence structuré pour Buroxia</a:t>
+              <a:t>Signature d'une collaboration avec Ayaa.lbns</a:t>
+            </a:r>
+          </a:p>
+          <a:p>
+            <a:pPr>
+              <a:spcAft>
+                <a:spcPts val="1200"/>
+              </a:spcAft>
+              <a:defRPr sz="1800">
+                <a:solidFill>
+                  <a:srgbClr val="333333"/>
+                </a:solidFill>
+              </a:defRPr>
+            </a:pPr>
+            <a:r>
+              <a:t>Exposition de Buroxia auprès de l'audience de l'influenceuse</a:t>
+            </a:r>
+          </a:p>
+          <a:p>
+            <a:pPr>
+              <a:spcAft>
+                <a:spcPts val="1200"/>
+              </a:spcAft>
+              <a:defRPr sz="1800">
+                <a:solidFill>
+                  <a:srgbClr val="333333"/>
+                </a:solidFill>
+              </a:defRPr>
+            </a:pPr>
+            <a:r>
+              <a:t>Association à une créatrice reconnue pour son engagement social</a:t>
+            </a:r>
+          </a:p>
+          <a:p>
+            <a:pPr>
+              <a:spcAft>
+                <a:spcPts val="1200"/>
+              </a:spcAft>
+              <a:defRPr sz="1800">
+                <a:solidFill>
+                  <a:srgbClr val="333333"/>
+                </a:solidFill>
+              </a:defRPr>
+            </a:pPr>
+            <a:r>
+              <a:t>Livrables : Fiche de prestations, grille tarifaire, contrat signé</a:t>
+            </a:r>
+          </a:p>
+          <a:p>
+            <a:pPr>
+              <a:spcAft>
+                <a:spcPts val="1200"/>
+              </a:spcAft>
+              <a:defRPr sz="1800">
+                <a:solidFill>
+                  <a:srgbClr val="333333"/>
+                </a:solidFill>
+              </a:defRPr>
+            </a:pPr>
+            <a:r>
+              <a:t>Occupation : Mise à disposition d'un bureau pour 1 mois</a:t>
+            </a:r>
+          </a:p>
+          <a:p>
+            <a:pPr>
+              <a:spcAft>
+                <a:spcPts val="1200"/>
+              </a:spcAft>
+              <a:defRPr sz="1800">
+                <a:solidFill>
+                  <a:srgbClr val="333333"/>
+                </a:solidFill>
+              </a:defRPr>
+            </a:pPr>
+            <a:r>
+              <a:t>Impact : Premier partenariat influence structuré pour Buroxia</a:t>
             </a:r>
           </a:p>
         </p:txBody>
@@ -5249,82 +5249,82 @@
               </a:defRPr>
             </a:pPr>
             <a:r>
-              <a:t>💼 Premier partenariat influenceur réussi pour Buroxia</a:t>
-            </a:r>
-          </a:p>
-          <a:p>
-            <a:pPr>
-              <a:spcAft>
-                <a:spcPts val="1200"/>
-              </a:spcAft>
-              <a:defRPr sz="1800">
-                <a:solidFill>
-                  <a:srgbClr val="333333"/>
-                </a:solidFill>
-              </a:defRPr>
-            </a:pPr>
-            <a:r>
-              <a:t>📊 Crédibilité renforcée auprès de prospects et partenaires</a:t>
-            </a:r>
-          </a:p>
-          <a:p>
-            <a:pPr>
-              <a:spcAft>
-                <a:spcPts val="1200"/>
-              </a:spcAft>
-              <a:defRPr sz="1800">
-                <a:solidFill>
-                  <a:srgbClr val="333333"/>
-                </a:solidFill>
-              </a:defRPr>
-            </a:pPr>
-            <a:r>
-              <a:t>👁️ Visibilité élargie sur une cible qualifiée</a:t>
-            </a:r>
-          </a:p>
-          <a:p>
-            <a:pPr>
-              <a:spcAft>
-                <a:spcPts val="1200"/>
-              </a:spcAft>
-              <a:defRPr sz="1800">
-                <a:solidFill>
-                  <a:srgbClr val="333333"/>
-                </a:solidFill>
-              </a:defRPr>
-            </a:pPr>
-            <a:r>
-              <a:t>🔄 Outils commerciaux réutilisables (fiche, grille tarifaire)</a:t>
-            </a:r>
-          </a:p>
-          <a:p>
-            <a:pPr>
-              <a:spcAft>
-                <a:spcPts val="1200"/>
-              </a:spcAft>
-              <a:defRPr sz="1800">
-                <a:solidFill>
-                  <a:srgbClr val="333333"/>
-                </a:solidFill>
-              </a:defRPr>
-            </a:pPr>
-            <a:r>
-              <a:t>🚪 Ouverture vers de futures collaborations d'influence</a:t>
-            </a:r>
-          </a:p>
-          <a:p>
-            <a:pPr>
-              <a:spcAft>
-                <a:spcPts val="1200"/>
-              </a:spcAft>
-              <a:defRPr sz="1800">
-                <a:solidFill>
-                  <a:srgbClr val="333333"/>
-                </a:solidFill>
-              </a:defRPr>
-            </a:pPr>
-            <a:r>
-              <a:t>🎯 Stratégie digitale structurée et opérationnelle</a:t>
+              <a:t>Premier partenariat influenceur réussi pour Buroxia</a:t>
+            </a:r>
+          </a:p>
+          <a:p>
+            <a:pPr>
+              <a:spcAft>
+                <a:spcPts val="1200"/>
+              </a:spcAft>
+              <a:defRPr sz="1800">
+                <a:solidFill>
+                  <a:srgbClr val="333333"/>
+                </a:solidFill>
+              </a:defRPr>
+            </a:pPr>
+            <a:r>
+              <a:t>Crédibilité renforcée auprès de prospects et partenaires</a:t>
+            </a:r>
+          </a:p>
+          <a:p>
+            <a:pPr>
+              <a:spcAft>
+                <a:spcPts val="1200"/>
+              </a:spcAft>
+              <a:defRPr sz="1800">
+                <a:solidFill>
+                  <a:srgbClr val="333333"/>
+                </a:solidFill>
+              </a:defRPr>
+            </a:pPr>
+            <a:r>
+              <a:t>Visibilité élargie sur une cible qualifiée</a:t>
+            </a:r>
+          </a:p>
+          <a:p>
+            <a:pPr>
+              <a:spcAft>
+                <a:spcPts val="1200"/>
+              </a:spcAft>
+              <a:defRPr sz="1800">
+                <a:solidFill>
+                  <a:srgbClr val="333333"/>
+                </a:solidFill>
+              </a:defRPr>
+            </a:pPr>
+            <a:r>
+              <a:t>Outils commerciaux réutilisables (fiche, grille tarifaire)</a:t>
+            </a:r>
+          </a:p>
+          <a:p>
+            <a:pPr>
+              <a:spcAft>
+                <a:spcPts val="1200"/>
+              </a:spcAft>
+              <a:defRPr sz="1800">
+                <a:solidFill>
+                  <a:srgbClr val="333333"/>
+                </a:solidFill>
+              </a:defRPr>
+            </a:pPr>
+            <a:r>
+              <a:t>Ouverture vers de futures collaborations d'influence</a:t>
+            </a:r>
+          </a:p>
+          <a:p>
+            <a:pPr>
+              <a:spcAft>
+                <a:spcPts val="1200"/>
+              </a:spcAft>
+              <a:defRPr sz="1800">
+                <a:solidFill>
+                  <a:srgbClr val="333333"/>
+                </a:solidFill>
+              </a:defRPr>
+            </a:pPr>
+            <a:r>
+              <a:t>Stratégie digitale structurée et opérationnelle</a:t>
             </a:r>
           </a:p>
         </p:txBody>
@@ -5505,67 +5505,67 @@
               </a:defRPr>
             </a:pPr>
             <a:r>
-              <a:t>✅ Points forts : Initiative, persévérance, opportunité saisie</a:t>
-            </a:r>
-          </a:p>
-          <a:p>
-            <a:pPr>
-              <a:spcAft>
-                <a:spcPts val="1200"/>
-              </a:spcAft>
-              <a:defRPr sz="1800">
-                <a:solidFill>
-                  <a:srgbClr val="333333"/>
-                </a:solidFill>
-              </a:defRPr>
-            </a:pPr>
-            <a:r>
-              <a:t>⚠️ Difficultés : Refus initiaux, faible notoriété, coordination à distance</a:t>
-            </a:r>
-          </a:p>
-          <a:p>
-            <a:pPr>
-              <a:spcAft>
-                <a:spcPts val="1200"/>
-              </a:spcAft>
-              <a:defRPr sz="1800">
-                <a:solidFill>
-                  <a:srgbClr val="333333"/>
-                </a:solidFill>
-              </a:defRPr>
-            </a:pPr>
-            <a:r>
-              <a:t>🔄 Amélioration possible : Processus de prospection systématisé</a:t>
-            </a:r>
-          </a:p>
-          <a:p>
-            <a:pPr>
-              <a:spcAft>
-                <a:spcPts val="1200"/>
-              </a:spcAft>
-              <a:defRPr sz="1800">
-                <a:solidFill>
-                  <a:srgbClr val="333333"/>
-                </a:solidFill>
-              </a:defRPr>
-            </a:pPr>
-            <a:r>
-              <a:t>📊 Recommandation : Mesurer les retombées (portée, engagement, leads)</a:t>
-            </a:r>
-          </a:p>
-          <a:p>
-            <a:pPr>
-              <a:spcAft>
-                <a:spcPts val="1200"/>
-              </a:spcAft>
-              <a:defRPr sz="1800">
-                <a:solidFill>
-                  <a:srgbClr val="333333"/>
-                </a:solidFill>
-              </a:defRPr>
-            </a:pPr>
-            <a:r>
-              <a:t>💡 Enseignement : Alignement des intérêts &gt; Notoriété du profil</a:t>
+              <a:t>Points forts : Initiative, persévérance, opportunité saisie</a:t>
+            </a:r>
+          </a:p>
+          <a:p>
+            <a:pPr>
+              <a:spcAft>
+                <a:spcPts val="1200"/>
+              </a:spcAft>
+              <a:defRPr sz="1800">
+                <a:solidFill>
+                  <a:srgbClr val="333333"/>
+                </a:solidFill>
+              </a:defRPr>
+            </a:pPr>
+            <a:r>
+              <a:t>Difficultés : Refus initiaux, faible notoriété, coordination à distance</a:t>
+            </a:r>
+          </a:p>
+          <a:p>
+            <a:pPr>
+              <a:spcAft>
+                <a:spcPts val="1200"/>
+              </a:spcAft>
+              <a:defRPr sz="1800">
+                <a:solidFill>
+                  <a:srgbClr val="333333"/>
+                </a:solidFill>
+              </a:defRPr>
+            </a:pPr>
+            <a:r>
+              <a:t>Amélioration possible : Processus de prospection systématisé</a:t>
+            </a:r>
+          </a:p>
+          <a:p>
+            <a:pPr>
+              <a:spcAft>
+                <a:spcPts val="1200"/>
+              </a:spcAft>
+              <a:defRPr sz="1800">
+                <a:solidFill>
+                  <a:srgbClr val="333333"/>
+                </a:solidFill>
+              </a:defRPr>
+            </a:pPr>
+            <a:r>
+              <a:t>Recommandation : Mesurer les retombées (portée, engagement, leads)</a:t>
+            </a:r>
+          </a:p>
+          <a:p>
+            <a:pPr>
+              <a:spcAft>
+                <a:spcPts val="1200"/>
+              </a:spcAft>
+              <a:defRPr sz="1800">
+                <a:solidFill>
+                  <a:srgbClr val="333333"/>
+                </a:solidFill>
+              </a:defRPr>
+            </a:pPr>
+            <a:r>
+              <a:t>Enseignement : Alignement des intérêts &gt; Notoriété du profil</a:t>
             </a:r>
           </a:p>
         </p:txBody>
@@ -5746,97 +5746,97 @@
               </a:defRPr>
             </a:pPr>
             <a:r>
-              <a:t>🔍 Prospection de partenaires influenceurs (veille, ciblage, contact)</a:t>
-            </a:r>
-          </a:p>
-          <a:p>
-            <a:pPr>
-              <a:spcAft>
-                <a:spcPts val="1200"/>
-              </a:spcAft>
-              <a:defRPr sz="1800">
-                <a:solidFill>
-                  <a:srgbClr val="333333"/>
-                </a:solidFill>
-              </a:defRPr>
-            </a:pPr>
-            <a:r>
-              <a:t>📝 Rédaction de supports commerciaux structurés</a:t>
-            </a:r>
-          </a:p>
-          <a:p>
-            <a:pPr>
-              <a:spcAft>
-                <a:spcPts val="1200"/>
-              </a:spcAft>
-              <a:defRPr sz="1800">
-                <a:solidFill>
-                  <a:srgbClr val="333333"/>
-                </a:solidFill>
-              </a:defRPr>
-            </a:pPr>
-            <a:r>
-              <a:t>🎨 Création de contenus visuels et vidéo (Canva, montage)</a:t>
-            </a:r>
-          </a:p>
-          <a:p>
-            <a:pPr>
-              <a:spcAft>
-                <a:spcPts val="1200"/>
-              </a:spcAft>
-              <a:defRPr sz="1800">
-                <a:solidFill>
-                  <a:srgbClr val="333333"/>
-                </a:solidFill>
-              </a:defRPr>
-            </a:pPr>
-            <a:r>
-              <a:t>📅 Organisation et animation de réunions (visio et présentiel)</a:t>
-            </a:r>
-          </a:p>
-          <a:p>
-            <a:pPr>
-              <a:spcAft>
-                <a:spcPts val="1200"/>
-              </a:spcAft>
-              <a:defRPr sz="1800">
-                <a:solidFill>
-                  <a:srgbClr val="333333"/>
-                </a:solidFill>
-              </a:defRPr>
-            </a:pPr>
-            <a:r>
-              <a:t>💬 Négociation et construction d'offres gagnant-gagnant</a:t>
-            </a:r>
-          </a:p>
-          <a:p>
-            <a:pPr>
-              <a:spcAft>
-                <a:spcPts val="1200"/>
-              </a:spcAft>
-              <a:defRPr sz="1800">
-                <a:solidFill>
-                  <a:srgbClr val="333333"/>
-                </a:solidFill>
-              </a:defRPr>
-            </a:pPr>
-            <a:r>
-              <a:t>📈 Contribution à une stratégie de visibilité par l'influence</a:t>
-            </a:r>
-          </a:p>
-          <a:p>
-            <a:pPr>
-              <a:spcAft>
-                <a:spcPts val="1200"/>
-              </a:spcAft>
-              <a:defRPr sz="1800">
-                <a:solidFill>
-                  <a:srgbClr val="333333"/>
-                </a:solidFill>
-              </a:defRPr>
-            </a:pPr>
-            <a:r>
-              <a:t>🤝 Gestion de projet et coordination multi-parties</a:t>
+              <a:t>Prospection de partenaires influenceurs (veille, ciblage, contact)</a:t>
+            </a:r>
+          </a:p>
+          <a:p>
+            <a:pPr>
+              <a:spcAft>
+                <a:spcPts val="1200"/>
+              </a:spcAft>
+              <a:defRPr sz="1800">
+                <a:solidFill>
+                  <a:srgbClr val="333333"/>
+                </a:solidFill>
+              </a:defRPr>
+            </a:pPr>
+            <a:r>
+              <a:t>Rédaction de supports commerciaux structurés</a:t>
+            </a:r>
+          </a:p>
+          <a:p>
+            <a:pPr>
+              <a:spcAft>
+                <a:spcPts val="1200"/>
+              </a:spcAft>
+              <a:defRPr sz="1800">
+                <a:solidFill>
+                  <a:srgbClr val="333333"/>
+                </a:solidFill>
+              </a:defRPr>
+            </a:pPr>
+            <a:r>
+              <a:t>Création de contenus visuels et vidéo (Canva, montage)</a:t>
+            </a:r>
+          </a:p>
+          <a:p>
+            <a:pPr>
+              <a:spcAft>
+                <a:spcPts val="1200"/>
+              </a:spcAft>
+              <a:defRPr sz="1800">
+                <a:solidFill>
+                  <a:srgbClr val="333333"/>
+                </a:solidFill>
+              </a:defRPr>
+            </a:pPr>
+            <a:r>
+              <a:t>Organisation et animation de réunions (visio et présentiel)</a:t>
+            </a:r>
+          </a:p>
+          <a:p>
+            <a:pPr>
+              <a:spcAft>
+                <a:spcPts val="1200"/>
+              </a:spcAft>
+              <a:defRPr sz="1800">
+                <a:solidFill>
+                  <a:srgbClr val="333333"/>
+                </a:solidFill>
+              </a:defRPr>
+            </a:pPr>
+            <a:r>
+              <a:t>Négociation et construction d'offres gagnant-gagnant</a:t>
+            </a:r>
+          </a:p>
+          <a:p>
+            <a:pPr>
+              <a:spcAft>
+                <a:spcPts val="1200"/>
+              </a:spcAft>
+              <a:defRPr sz="1800">
+                <a:solidFill>
+                  <a:srgbClr val="333333"/>
+                </a:solidFill>
+              </a:defRPr>
+            </a:pPr>
+            <a:r>
+              <a:t>Contribution à une stratégie de visibilité par l'influence</a:t>
+            </a:r>
+          </a:p>
+          <a:p>
+            <a:pPr>
+              <a:spcAft>
+                <a:spcPts val="1200"/>
+              </a:spcAft>
+              <a:defRPr sz="1800">
+                <a:solidFill>
+                  <a:srgbClr val="333333"/>
+                </a:solidFill>
+              </a:defRPr>
+            </a:pPr>
+            <a:r>
+              <a:t>Gestion de projet et coordination multi-parties</a:t>
             </a:r>
           </a:p>
         </p:txBody>
@@ -6258,82 +6258,82 @@
               </a:defRPr>
             </a:pPr>
             <a:r>
-              <a:t>💪 Persévérance face aux refus</a:t>
-            </a:r>
-          </a:p>
-          <a:p>
-            <a:pPr>
-              <a:spcAft>
-                <a:spcPts val="1200"/>
-              </a:spcAft>
-              <a:defRPr sz="1800">
-                <a:solidFill>
-                  <a:srgbClr val="333333"/>
-                </a:solidFill>
-              </a:defRPr>
-            </a:pPr>
-            <a:r>
-              <a:t>💡 Initiative et prise de responsabilité</a:t>
-            </a:r>
-          </a:p>
-          <a:p>
-            <a:pPr>
-              <a:spcAft>
-                <a:spcPts val="1200"/>
-              </a:spcAft>
-              <a:defRPr sz="1800">
-                <a:solidFill>
-                  <a:srgbClr val="333333"/>
-                </a:solidFill>
-              </a:defRPr>
-            </a:pPr>
-            <a:r>
-              <a:t>✍️ Rigueur rédactionnelle et professionnelle</a:t>
-            </a:r>
-          </a:p>
-          <a:p>
-            <a:pPr>
-              <a:spcAft>
-                <a:spcPts val="1200"/>
-              </a:spcAft>
-              <a:defRPr sz="1800">
-                <a:solidFill>
-                  <a:srgbClr val="333333"/>
-                </a:solidFill>
-              </a:defRPr>
-            </a:pPr>
-            <a:r>
-              <a:t>🤝 Diplomatie en situation de négociation</a:t>
-            </a:r>
-          </a:p>
-          <a:p>
-            <a:pPr>
-              <a:spcAft>
-                <a:spcPts val="1200"/>
-              </a:spcAft>
-              <a:defRPr sz="1800">
-                <a:solidFill>
-                  <a:srgbClr val="333333"/>
-                </a:solidFill>
-              </a:defRPr>
-            </a:pPr>
-            <a:r>
-              <a:t>🎯 Capacité à représenter une entreprise avec crédibilité</a:t>
-            </a:r>
-          </a:p>
-          <a:p>
-            <a:pPr>
-              <a:spcAft>
-                <a:spcPts val="1200"/>
-              </a:spcAft>
-              <a:defRPr sz="1800">
-                <a:solidFill>
-                  <a:srgbClr val="333333"/>
-                </a:solidFill>
-              </a:defRPr>
-            </a:pPr>
-            <a:r>
-              <a:t>⚡ Réactivité et saisie d'opportunités en temps réel</a:t>
+              <a:t>Persévérance face aux refus</a:t>
+            </a:r>
+          </a:p>
+          <a:p>
+            <a:pPr>
+              <a:spcAft>
+                <a:spcPts val="1200"/>
+              </a:spcAft>
+              <a:defRPr sz="1800">
+                <a:solidFill>
+                  <a:srgbClr val="333333"/>
+                </a:solidFill>
+              </a:defRPr>
+            </a:pPr>
+            <a:r>
+              <a:t>Initiative et prise de responsabilité</a:t>
+            </a:r>
+          </a:p>
+          <a:p>
+            <a:pPr>
+              <a:spcAft>
+                <a:spcPts val="1200"/>
+              </a:spcAft>
+              <a:defRPr sz="1800">
+                <a:solidFill>
+                  <a:srgbClr val="333333"/>
+                </a:solidFill>
+              </a:defRPr>
+            </a:pPr>
+            <a:r>
+              <a:t>Rigueur rédactionnelle et professionnelle</a:t>
+            </a:r>
+          </a:p>
+          <a:p>
+            <a:pPr>
+              <a:spcAft>
+                <a:spcPts val="1200"/>
+              </a:spcAft>
+              <a:defRPr sz="1800">
+                <a:solidFill>
+                  <a:srgbClr val="333333"/>
+                </a:solidFill>
+              </a:defRPr>
+            </a:pPr>
+            <a:r>
+              <a:t>Diplomatie en situation de négociation</a:t>
+            </a:r>
+          </a:p>
+          <a:p>
+            <a:pPr>
+              <a:spcAft>
+                <a:spcPts val="1200"/>
+              </a:spcAft>
+              <a:defRPr sz="1800">
+                <a:solidFill>
+                  <a:srgbClr val="333333"/>
+                </a:solidFill>
+              </a:defRPr>
+            </a:pPr>
+            <a:r>
+              <a:t>Capacité à représenter une entreprise avec crédibilité</a:t>
+            </a:r>
+          </a:p>
+          <a:p>
+            <a:pPr>
+              <a:spcAft>
+                <a:spcPts val="1200"/>
+              </a:spcAft>
+              <a:defRPr sz="1800">
+                <a:solidFill>
+                  <a:srgbClr val="333333"/>
+                </a:solidFill>
+              </a:defRPr>
+            </a:pPr>
+            <a:r>
+              <a:t>Réactivité et saisie d'opportunités en temps réel</a:t>
             </a:r>
           </a:p>
         </p:txBody>
@@ -6514,82 +6514,82 @@
               </a:defRPr>
             </a:pPr>
             <a:r>
-              <a:t>✅ Expérience formatrice et concrète</a:t>
-            </a:r>
-          </a:p>
-          <a:p>
-            <a:pPr>
-              <a:spcAft>
-                <a:spcPts val="1200"/>
-              </a:spcAft>
-              <a:defRPr sz="1800">
-                <a:solidFill>
-                  <a:srgbClr val="333333"/>
-                </a:solidFill>
-              </a:defRPr>
-            </a:pPr>
-            <a:r>
-              <a:t>🚀 Confirmation de mon intérêt pour la communication digitale</a:t>
-            </a:r>
-          </a:p>
-          <a:p>
-            <a:pPr>
-              <a:spcAft>
-                <a:spcPts val="1200"/>
-              </a:spcAft>
-              <a:defRPr sz="1800">
-                <a:solidFill>
-                  <a:srgbClr val="333333"/>
-                </a:solidFill>
-              </a:defRPr>
-            </a:pPr>
-            <a:r>
-              <a:t>🎯 Passion confirmée pour le marketing d'influence</a:t>
-            </a:r>
-          </a:p>
-          <a:p>
-            <a:pPr>
-              <a:spcAft>
-                <a:spcPts val="1200"/>
-              </a:spcAft>
-              <a:defRPr sz="1800">
-                <a:solidFill>
-                  <a:srgbClr val="333333"/>
-                </a:solidFill>
-              </a:defRPr>
-            </a:pPr>
-            <a:r>
-              <a:t>💼 Développement de compétences opérationnelles et stratégiques</a:t>
-            </a:r>
-          </a:p>
-          <a:p>
-            <a:pPr>
-              <a:spcAft>
-                <a:spcPts val="1200"/>
-              </a:spcAft>
-              <a:defRPr sz="1800">
-                <a:solidFill>
-                  <a:srgbClr val="333333"/>
-                </a:solidFill>
-              </a:defRPr>
-            </a:pPr>
-            <a:r>
-              <a:t>🤝 Travail en autonomie et collaboration avec la direction</a:t>
-            </a:r>
-          </a:p>
-          <a:p>
-            <a:pPr>
-              <a:spcAft>
-                <a:spcPts val="1200"/>
-              </a:spcAft>
-              <a:defRPr sz="1800">
-                <a:solidFill>
-                  <a:srgbClr val="333333"/>
-                </a:solidFill>
-              </a:defRPr>
-            </a:pPr>
-            <a:r>
-              <a:t>📈 Capacité à mener un projet stratégique de bout en bout</a:t>
+              <a:t>Expérience formatrice et concrète</a:t>
+            </a:r>
+          </a:p>
+          <a:p>
+            <a:pPr>
+              <a:spcAft>
+                <a:spcPts val="1200"/>
+              </a:spcAft>
+              <a:defRPr sz="1800">
+                <a:solidFill>
+                  <a:srgbClr val="333333"/>
+                </a:solidFill>
+              </a:defRPr>
+            </a:pPr>
+            <a:r>
+              <a:t>Confirmation de mon intérêt pour la communication digitale</a:t>
+            </a:r>
+          </a:p>
+          <a:p>
+            <a:pPr>
+              <a:spcAft>
+                <a:spcPts val="1200"/>
+              </a:spcAft>
+              <a:defRPr sz="1800">
+                <a:solidFill>
+                  <a:srgbClr val="333333"/>
+                </a:solidFill>
+              </a:defRPr>
+            </a:pPr>
+            <a:r>
+              <a:t>Passion confirmée pour le marketing d'influence</a:t>
+            </a:r>
+          </a:p>
+          <a:p>
+            <a:pPr>
+              <a:spcAft>
+                <a:spcPts val="1200"/>
+              </a:spcAft>
+              <a:defRPr sz="1800">
+                <a:solidFill>
+                  <a:srgbClr val="333333"/>
+                </a:solidFill>
+              </a:defRPr>
+            </a:pPr>
+            <a:r>
+              <a:t>Développement de compétences opérationnelles et stratégiques</a:t>
+            </a:r>
+          </a:p>
+          <a:p>
+            <a:pPr>
+              <a:spcAft>
+                <a:spcPts val="1200"/>
+              </a:spcAft>
+              <a:defRPr sz="1800">
+                <a:solidFill>
+                  <a:srgbClr val="333333"/>
+                </a:solidFill>
+              </a:defRPr>
+            </a:pPr>
+            <a:r>
+              <a:t>Travail en autonomie et collaboration avec la direction</a:t>
+            </a:r>
+          </a:p>
+          <a:p>
+            <a:pPr>
+              <a:spcAft>
+                <a:spcPts val="1200"/>
+              </a:spcAft>
+              <a:defRPr sz="1800">
+                <a:solidFill>
+                  <a:srgbClr val="333333"/>
+                </a:solidFill>
+              </a:defRPr>
+            </a:pPr>
+            <a:r>
+              <a:t>Capacité à mener un projet stratégique de bout en bout</a:t>
             </a:r>
           </a:p>
         </p:txBody>
@@ -6805,7 +6805,7 @@
               </a:defRPr>
             </a:pPr>
             <a:r>
-              <a:t>🎯 Orientation : Stratégies de visibilité pour les marques</a:t>
+              <a:t>Orientation : Stratégies de visibilité pour les marques</a:t>
             </a:r>
           </a:p>
           <a:p>
@@ -6820,7 +6820,7 @@
               </a:defRPr>
             </a:pPr>
             <a:r>
-              <a:t>💡 Objectif : Concevoir et piloter des projets d'influence</a:t>
+              <a:t>Objectif : Concevoir et piloter des projets d'influence</a:t>
             </a:r>
           </a:p>
           <a:p>
@@ -6835,7 +6835,7 @@
               </a:defRPr>
             </a:pPr>
             <a:r>
-              <a:t>🔗 Combinaison : Contenu créatif + Performance commerciale</a:t>
+              <a:t>Combinaison : Contenu créatif + Performance commerciale</a:t>
             </a:r>
           </a:p>
           <a:p>
@@ -6850,7 +6850,7 @@
               </a:defRPr>
             </a:pPr>
             <a:r>
-              <a:t>🚀 Ambition : Accompagner les marques dans leur transformation digitale</a:t>
+              <a:t>Ambition : Accompagner les marques dans leur transformation digitale</a:t>
             </a:r>
           </a:p>
         </p:txBody>
@@ -7031,82 +7031,82 @@
               </a:defRPr>
             </a:pPr>
             <a:r>
-              <a:t>🏆 Mission phare réussie : De l'idée à la signature du contrat</a:t>
-            </a:r>
-          </a:p>
-          <a:p>
-            <a:pPr>
-              <a:spcAft>
-                <a:spcPts val="1200"/>
-              </a:spcAft>
-              <a:defRPr sz="1800">
-                <a:solidFill>
-                  <a:srgbClr val="333333"/>
-                </a:solidFill>
-              </a:defRPr>
-            </a:pPr>
-            <a:r>
-              <a:t>💼 Responsabilité assumée sur un projet stratégique</a:t>
-            </a:r>
-          </a:p>
-          <a:p>
-            <a:pPr>
-              <a:spcAft>
-                <a:spcPts val="1200"/>
-              </a:spcAft>
-              <a:defRPr sz="1800">
-                <a:solidFill>
-                  <a:srgbClr val="333333"/>
-                </a:solidFill>
-              </a:defRPr>
-            </a:pPr>
-            <a:r>
-              <a:t>📈 Contribution concrète au développement de Buroxia</a:t>
-            </a:r>
-          </a:p>
-          <a:p>
-            <a:pPr>
-              <a:spcAft>
-                <a:spcPts val="1200"/>
-              </a:spcAft>
-              <a:defRPr sz="1800">
-                <a:solidFill>
-                  <a:srgbClr val="333333"/>
-                </a:solidFill>
-              </a:defRPr>
-            </a:pPr>
-            <a:r>
-              <a:t>🎓 Compétences développées : prospection, négociation, création</a:t>
-            </a:r>
-          </a:p>
-          <a:p>
-            <a:pPr>
-              <a:spcAft>
-                <a:spcPts val="1200"/>
-              </a:spcAft>
-              <a:defRPr sz="1800">
-                <a:solidFill>
-                  <a:srgbClr val="333333"/>
-                </a:solidFill>
-              </a:defRPr>
-            </a:pPr>
-            <a:r>
-              <a:t>✨ Expérience valorisante pour mon projet professionnel</a:t>
-            </a:r>
-          </a:p>
-          <a:p>
-            <a:pPr>
-              <a:spcAft>
-                <a:spcPts val="1200"/>
-              </a:spcAft>
-              <a:defRPr sz="1800">
-                <a:solidFill>
-                  <a:srgbClr val="333333"/>
-                </a:solidFill>
-              </a:defRPr>
-            </a:pPr>
-            <a:r>
-              <a:t>🙏 Remerciements à Stephanne Heyoppe et à l'équipe Buroxia</a:t>
+              <a:t>Mission phare réussie : De l'idée à la signature du contrat</a:t>
+            </a:r>
+          </a:p>
+          <a:p>
+            <a:pPr>
+              <a:spcAft>
+                <a:spcPts val="1200"/>
+              </a:spcAft>
+              <a:defRPr sz="1800">
+                <a:solidFill>
+                  <a:srgbClr val="333333"/>
+                </a:solidFill>
+              </a:defRPr>
+            </a:pPr>
+            <a:r>
+              <a:t>Responsabilité assumée sur un projet stratégique</a:t>
+            </a:r>
+          </a:p>
+          <a:p>
+            <a:pPr>
+              <a:spcAft>
+                <a:spcPts val="1200"/>
+              </a:spcAft>
+              <a:defRPr sz="1800">
+                <a:solidFill>
+                  <a:srgbClr val="333333"/>
+                </a:solidFill>
+              </a:defRPr>
+            </a:pPr>
+            <a:r>
+              <a:t>Contribution concrète au développement de Buroxia</a:t>
+            </a:r>
+          </a:p>
+          <a:p>
+            <a:pPr>
+              <a:spcAft>
+                <a:spcPts val="1200"/>
+              </a:spcAft>
+              <a:defRPr sz="1800">
+                <a:solidFill>
+                  <a:srgbClr val="333333"/>
+                </a:solidFill>
+              </a:defRPr>
+            </a:pPr>
+            <a:r>
+              <a:t>Compétences développées : prospection, négociation, création</a:t>
+            </a:r>
+          </a:p>
+          <a:p>
+            <a:pPr>
+              <a:spcAft>
+                <a:spcPts val="1200"/>
+              </a:spcAft>
+              <a:defRPr sz="1800">
+                <a:solidFill>
+                  <a:srgbClr val="333333"/>
+                </a:solidFill>
+              </a:defRPr>
+            </a:pPr>
+            <a:r>
+              <a:t>Expérience valorisante pour mon projet professionnel</a:t>
+            </a:r>
+          </a:p>
+          <a:p>
+            <a:pPr>
+              <a:spcAft>
+                <a:spcPts val="1200"/>
+              </a:spcAft>
+              <a:defRPr sz="1800">
+                <a:solidFill>
+                  <a:srgbClr val="333333"/>
+                </a:solidFill>
+              </a:defRPr>
+            </a:pPr>
+            <a:r>
+              <a:t>Remerciements à Stephanne Heyoppe et à l'équipe Buroxia</a:t>
             </a:r>
           </a:p>
         </p:txBody>
@@ -7420,67 +7420,67 @@
               </a:defRPr>
             </a:pPr>
             <a:r>
-              <a:t>🎓 Stage de 3 mois : Février à Avril 2026</a:t>
-            </a:r>
-          </a:p>
-          <a:p>
-            <a:pPr>
-              <a:spcAft>
-                <a:spcPts val="1200"/>
-              </a:spcAft>
-              <a:defRPr sz="1800">
-                <a:solidFill>
-                  <a:srgbClr val="333333"/>
-                </a:solidFill>
-              </a:defRPr>
-            </a:pPr>
-            <a:r>
-              <a:t>🏢 Entreprise : Buroxia (Prado Affaires), centre d'affaires à Marseille</a:t>
-            </a:r>
-          </a:p>
-          <a:p>
-            <a:pPr>
-              <a:spcAft>
-                <a:spcPts val="1200"/>
-              </a:spcAft>
-              <a:defRPr sz="1800">
-                <a:solidFill>
-                  <a:srgbClr val="333333"/>
-                </a:solidFill>
-              </a:defRPr>
-            </a:pPr>
-            <a:r>
-              <a:t>💼 Poste : Community Manager</a:t>
-            </a:r>
-          </a:p>
-          <a:p>
-            <a:pPr>
-              <a:spcAft>
-                <a:spcPts val="1200"/>
-              </a:spcAft>
-              <a:defRPr sz="1800">
-                <a:solidFill>
-                  <a:srgbClr val="333333"/>
-                </a:solidFill>
-              </a:defRPr>
-            </a:pPr>
-            <a:r>
-              <a:t>🎯 Objectif : Développer la visibilité digitale et la notoriété</a:t>
-            </a:r>
-          </a:p>
-          <a:p>
-            <a:pPr>
-              <a:spcAft>
-                <a:spcPts val="1200"/>
-              </a:spcAft>
-              <a:defRPr sz="1800">
-                <a:solidFill>
-                  <a:srgbClr val="333333"/>
-                </a:solidFill>
-              </a:defRPr>
-            </a:pPr>
-            <a:r>
-              <a:t>⭐ Mission phare : Partenariat avec l'influenceuse Ayaa.lbns</a:t>
+              <a:t>Stage de 3 mois : Février à Avril 2026</a:t>
+            </a:r>
+          </a:p>
+          <a:p>
+            <a:pPr>
+              <a:spcAft>
+                <a:spcPts val="1200"/>
+              </a:spcAft>
+              <a:defRPr sz="1800">
+                <a:solidFill>
+                  <a:srgbClr val="333333"/>
+                </a:solidFill>
+              </a:defRPr>
+            </a:pPr>
+            <a:r>
+              <a:t>Entreprise : Buroxia (Prado Affaires), centre d'affaires à Marseille</a:t>
+            </a:r>
+          </a:p>
+          <a:p>
+            <a:pPr>
+              <a:spcAft>
+                <a:spcPts val="1200"/>
+              </a:spcAft>
+              <a:defRPr sz="1800">
+                <a:solidFill>
+                  <a:srgbClr val="333333"/>
+                </a:solidFill>
+              </a:defRPr>
+            </a:pPr>
+            <a:r>
+              <a:t>Poste : Community Manager</a:t>
+            </a:r>
+          </a:p>
+          <a:p>
+            <a:pPr>
+              <a:spcAft>
+                <a:spcPts val="1200"/>
+              </a:spcAft>
+              <a:defRPr sz="1800">
+                <a:solidFill>
+                  <a:srgbClr val="333333"/>
+                </a:solidFill>
+              </a:defRPr>
+            </a:pPr>
+            <a:r>
+              <a:t>Objectif : Développer la visibilité digitale et la notoriété</a:t>
+            </a:r>
+          </a:p>
+          <a:p>
+            <a:pPr>
+              <a:spcAft>
+                <a:spcPts val="1200"/>
+              </a:spcAft>
+              <a:defRPr sz="1800">
+                <a:solidFill>
+                  <a:srgbClr val="333333"/>
+                </a:solidFill>
+              </a:defRPr>
+            </a:pPr>
+            <a:r>
+              <a:t>Mission phare : Partenariat avec l'influenceuse Ayaa.lbns</a:t>
             </a:r>
           </a:p>
         </p:txBody>
@@ -7661,82 +7661,82 @@
               </a:defRPr>
             </a:pPr>
             <a:r>
-              <a:t>📍 Centre d'affaires situé 24 avenue du Prado, Marseille 6e</a:t>
-            </a:r>
-          </a:p>
-          <a:p>
-            <a:pPr>
-              <a:spcAft>
-                <a:spcPts val="1200"/>
-              </a:spcAft>
-              <a:defRPr sz="1800">
-                <a:solidFill>
-                  <a:srgbClr val="333333"/>
-                </a:solidFill>
-              </a:defRPr>
-            </a:pPr>
-            <a:r>
-              <a:t>📐 330 m² d'espaces professionnels</a:t>
-            </a:r>
-          </a:p>
-          <a:p>
-            <a:pPr>
-              <a:spcAft>
-                <a:spcPts val="1200"/>
-              </a:spcAft>
-              <a:defRPr sz="1800">
-                <a:solidFill>
-                  <a:srgbClr val="333333"/>
-                </a:solidFill>
-              </a:defRPr>
-            </a:pPr>
-            <a:r>
-              <a:t>📅 Plus de 15 ans d'expérience</a:t>
-            </a:r>
-          </a:p>
-          <a:p>
-            <a:pPr>
-              <a:spcAft>
-                <a:spcPts val="1200"/>
-              </a:spcAft>
-              <a:defRPr sz="1800">
-                <a:solidFill>
-                  <a:srgbClr val="333333"/>
-                </a:solidFill>
-              </a:defRPr>
-            </a:pPr>
-            <a:r>
-              <a:t>✅ Services : Domiciliation, bureaux équipés, salles de réunion</a:t>
-            </a:r>
-          </a:p>
-          <a:p>
-            <a:pPr>
-              <a:spcAft>
-                <a:spcPts val="1200"/>
-              </a:spcAft>
-              <a:defRPr sz="1800">
-                <a:solidFill>
-                  <a:srgbClr val="333333"/>
-                </a:solidFill>
-              </a:defRPr>
-            </a:pPr>
-            <a:r>
-              <a:t>👥 Clients : Entrepreneurs, TPE, professions libérales, influenceurs</a:t>
-            </a:r>
-          </a:p>
-          <a:p>
-            <a:pPr>
-              <a:spcAft>
-                <a:spcPts val="1200"/>
-              </a:spcAft>
-              <a:defRPr sz="1800">
-                <a:solidFill>
-                  <a:srgbClr val="333333"/>
-                </a:solidFill>
-              </a:defRPr>
-            </a:pPr>
-            <a:r>
-              <a:t>🎯 Positionnement : Adresse prestigieuse et relation de proximité</a:t>
+              <a:t>Centre d'affaires situé 24 avenue du Prado, Marseille 6e</a:t>
+            </a:r>
+          </a:p>
+          <a:p>
+            <a:pPr>
+              <a:spcAft>
+                <a:spcPts val="1200"/>
+              </a:spcAft>
+              <a:defRPr sz="1800">
+                <a:solidFill>
+                  <a:srgbClr val="333333"/>
+                </a:solidFill>
+              </a:defRPr>
+            </a:pPr>
+            <a:r>
+              <a:t>330 m² d'espaces professionnels</a:t>
+            </a:r>
+          </a:p>
+          <a:p>
+            <a:pPr>
+              <a:spcAft>
+                <a:spcPts val="1200"/>
+              </a:spcAft>
+              <a:defRPr sz="1800">
+                <a:solidFill>
+                  <a:srgbClr val="333333"/>
+                </a:solidFill>
+              </a:defRPr>
+            </a:pPr>
+            <a:r>
+              <a:t>Plus de 15 ans d'expérience</a:t>
+            </a:r>
+          </a:p>
+          <a:p>
+            <a:pPr>
+              <a:spcAft>
+                <a:spcPts val="1200"/>
+              </a:spcAft>
+              <a:defRPr sz="1800">
+                <a:solidFill>
+                  <a:srgbClr val="333333"/>
+                </a:solidFill>
+              </a:defRPr>
+            </a:pPr>
+            <a:r>
+              <a:t>Services : Domiciliation, bureaux équipés, salles de réunion</a:t>
+            </a:r>
+          </a:p>
+          <a:p>
+            <a:pPr>
+              <a:spcAft>
+                <a:spcPts val="1200"/>
+              </a:spcAft>
+              <a:defRPr sz="1800">
+                <a:solidFill>
+                  <a:srgbClr val="333333"/>
+                </a:solidFill>
+              </a:defRPr>
+            </a:pPr>
+            <a:r>
+              <a:t>Clients : Entrepreneurs, TPE, professions libérales, influenceurs</a:t>
+            </a:r>
+          </a:p>
+          <a:p>
+            <a:pPr>
+              <a:spcAft>
+                <a:spcPts val="1200"/>
+              </a:spcAft>
+              <a:defRPr sz="1800">
+                <a:solidFill>
+                  <a:srgbClr val="333333"/>
+                </a:solidFill>
+              </a:defRPr>
+            </a:pPr>
+            <a:r>
+              <a:t>Positionnement : Adresse prestigieuse et relation de proximité</a:t>
             </a:r>
           </a:p>
         </p:txBody>
@@ -7917,67 +7917,67 @@
               </a:defRPr>
             </a:pPr>
             <a:r>
-              <a:t>🏙️ Marché marseillais des centres d'affaires très concurrentiel</a:t>
-            </a:r>
-          </a:p>
-          <a:p>
-            <a:pPr>
-              <a:spcAft>
-                <a:spcPts val="1200"/>
-              </a:spcAft>
-              <a:defRPr sz="1800">
-                <a:solidFill>
-                  <a:srgbClr val="333333"/>
-                </a:solidFill>
-              </a:defRPr>
-            </a:pPr>
-            <a:r>
-              <a:t>💡 Enjeu principal : Développer la visibilité et la notoriété</a:t>
-            </a:r>
-          </a:p>
-          <a:p>
-            <a:pPr>
-              <a:spcAft>
-                <a:spcPts val="1200"/>
-              </a:spcAft>
-              <a:defRPr sz="1800">
-                <a:solidFill>
-                  <a:srgbClr val="333333"/>
-                </a:solidFill>
-              </a:defRPr>
-            </a:pPr>
-            <a:r>
-              <a:t>📉 Problématique : Structure peu connue malgré une offre pertinente</a:t>
-            </a:r>
-          </a:p>
-          <a:p>
-            <a:pPr>
-              <a:spcAft>
-                <a:spcPts val="1200"/>
-              </a:spcAft>
-              <a:defRPr sz="1800">
-                <a:solidFill>
-                  <a:srgbClr val="333333"/>
-                </a:solidFill>
-              </a:defRPr>
-            </a:pPr>
-            <a:r>
-              <a:t>🚀 Solution : Stratégie digitale et marketing d'influence</a:t>
-            </a:r>
-          </a:p>
-          <a:p>
-            <a:pPr>
-              <a:spcAft>
-                <a:spcPts val="1200"/>
-              </a:spcAft>
-              <a:defRPr sz="1800">
-                <a:solidFill>
-                  <a:srgbClr val="333333"/>
-                </a:solidFill>
-              </a:defRPr>
-            </a:pPr>
-            <a:r>
-              <a:t>👤 Tuteur : Stephanne Heyoppe, propriétaire et directeur</a:t>
+              <a:t>Marché marseillais des centres d'affaires très concurrentiel</a:t>
+            </a:r>
+          </a:p>
+          <a:p>
+            <a:pPr>
+              <a:spcAft>
+                <a:spcPts val="1200"/>
+              </a:spcAft>
+              <a:defRPr sz="1800">
+                <a:solidFill>
+                  <a:srgbClr val="333333"/>
+                </a:solidFill>
+              </a:defRPr>
+            </a:pPr>
+            <a:r>
+              <a:t>Enjeu principal : Développer la visibilité et la notoriété</a:t>
+            </a:r>
+          </a:p>
+          <a:p>
+            <a:pPr>
+              <a:spcAft>
+                <a:spcPts val="1200"/>
+              </a:spcAft>
+              <a:defRPr sz="1800">
+                <a:solidFill>
+                  <a:srgbClr val="333333"/>
+                </a:solidFill>
+              </a:defRPr>
+            </a:pPr>
+            <a:r>
+              <a:t>Problématique : Structure peu connue malgré une offre pertinente</a:t>
+            </a:r>
+          </a:p>
+          <a:p>
+            <a:pPr>
+              <a:spcAft>
+                <a:spcPts val="1200"/>
+              </a:spcAft>
+              <a:defRPr sz="1800">
+                <a:solidFill>
+                  <a:srgbClr val="333333"/>
+                </a:solidFill>
+              </a:defRPr>
+            </a:pPr>
+            <a:r>
+              <a:t>Solution : Stratégie digitale et marketing d'influence</a:t>
+            </a:r>
+          </a:p>
+          <a:p>
+            <a:pPr>
+              <a:spcAft>
+                <a:spcPts val="1200"/>
+              </a:spcAft>
+              <a:defRPr sz="1800">
+                <a:solidFill>
+                  <a:srgbClr val="333333"/>
+                </a:solidFill>
+              </a:defRPr>
+            </a:pPr>
+            <a:r>
+              <a:t>Tuteur : Stephanne Heyoppe, propriétaire et directeur</a:t>
             </a:r>
           </a:p>
         </p:txBody>
@@ -8158,97 +8158,97 @@
               </a:defRPr>
             </a:pPr>
             <a:r>
-              <a:t>📱 Gestion des réseaux sociaux (Instagram, TikTok, LinkedIn, Facebook)</a:t>
-            </a:r>
-          </a:p>
-          <a:p>
-            <a:pPr>
-              <a:spcAft>
-                <a:spcPts val="1200"/>
-              </a:spcAft>
-              <a:defRPr sz="1800">
-                <a:solidFill>
-                  <a:srgbClr val="333333"/>
-                </a:solidFill>
-              </a:defRPr>
-            </a:pPr>
-            <a:r>
-              <a:t>🎨 Création de contenus visuels et vidéo (Canva, montage)</a:t>
-            </a:r>
-          </a:p>
-          <a:p>
-            <a:pPr>
-              <a:spcAft>
-                <a:spcPts val="1200"/>
-              </a:spcAft>
-              <a:defRPr sz="1800">
-                <a:solidFill>
-                  <a:srgbClr val="333333"/>
-                </a:solidFill>
-              </a:defRPr>
-            </a:pPr>
-            <a:r>
-              <a:t>📄 Refonte de supports commerciaux (plaquette, grille tarifaire)</a:t>
-            </a:r>
-          </a:p>
-          <a:p>
-            <a:pPr>
-              <a:spcAft>
-                <a:spcPts val="1200"/>
-              </a:spcAft>
-              <a:defRPr sz="1800">
-                <a:solidFill>
-                  <a:srgbClr val="333333"/>
-                </a:solidFill>
-              </a:defRPr>
-            </a:pPr>
-            <a:r>
-              <a:t>🌐 Mise à jour du site web WordPress</a:t>
-            </a:r>
-          </a:p>
-          <a:p>
-            <a:pPr>
-              <a:spcAft>
-                <a:spcPts val="1200"/>
-              </a:spcAft>
-              <a:defRPr sz="1800">
-                <a:solidFill>
-                  <a:srgbClr val="333333"/>
-                </a:solidFill>
-              </a:defRPr>
-            </a:pPr>
-            <a:r>
-              <a:t>📞 Prospection commerciale et rédaction de devis</a:t>
-            </a:r>
-          </a:p>
-          <a:p>
-            <a:pPr>
-              <a:spcAft>
-                <a:spcPts val="1200"/>
-              </a:spcAft>
-              <a:defRPr sz="1800">
-                <a:solidFill>
-                  <a:srgbClr val="333333"/>
-                </a:solidFill>
-              </a:defRPr>
-            </a:pPr>
-            <a:r>
-              <a:t>🤝 Accompagnement client et organisation de réunions</a:t>
-            </a:r>
-          </a:p>
-          <a:p>
-            <a:pPr>
-              <a:spcAft>
-                <a:spcPts val="1200"/>
-              </a:spcAft>
-              <a:defRPr sz="1800">
-                <a:solidFill>
-                  <a:srgbClr val="333333"/>
-                </a:solidFill>
-              </a:defRPr>
-            </a:pPr>
-            <a:r>
-              <a:t>⭐ Mission phare : Marketing d'influence avec Ayaa.lbns</a:t>
+              <a:t>Gestion des réseaux sociaux (Instagram, TikTok, LinkedIn, Facebook)</a:t>
+            </a:r>
+          </a:p>
+          <a:p>
+            <a:pPr>
+              <a:spcAft>
+                <a:spcPts val="1200"/>
+              </a:spcAft>
+              <a:defRPr sz="1800">
+                <a:solidFill>
+                  <a:srgbClr val="333333"/>
+                </a:solidFill>
+              </a:defRPr>
+            </a:pPr>
+            <a:r>
+              <a:t>Création de contenus visuels et vidéo (Canva, montage)</a:t>
+            </a:r>
+          </a:p>
+          <a:p>
+            <a:pPr>
+              <a:spcAft>
+                <a:spcPts val="1200"/>
+              </a:spcAft>
+              <a:defRPr sz="1800">
+                <a:solidFill>
+                  <a:srgbClr val="333333"/>
+                </a:solidFill>
+              </a:defRPr>
+            </a:pPr>
+            <a:r>
+              <a:t>Refonte de supports commerciaux (plaquette, grille tarifaire)</a:t>
+            </a:r>
+          </a:p>
+          <a:p>
+            <a:pPr>
+              <a:spcAft>
+                <a:spcPts val="1200"/>
+              </a:spcAft>
+              <a:defRPr sz="1800">
+                <a:solidFill>
+                  <a:srgbClr val="333333"/>
+                </a:solidFill>
+              </a:defRPr>
+            </a:pPr>
+            <a:r>
+              <a:t>Mise à jour du site web WordPress</a:t>
+            </a:r>
+          </a:p>
+          <a:p>
+            <a:pPr>
+              <a:spcAft>
+                <a:spcPts val="1200"/>
+              </a:spcAft>
+              <a:defRPr sz="1800">
+                <a:solidFill>
+                  <a:srgbClr val="333333"/>
+                </a:solidFill>
+              </a:defRPr>
+            </a:pPr>
+            <a:r>
+              <a:t>Prospection commerciale et rédaction de devis</a:t>
+            </a:r>
+          </a:p>
+          <a:p>
+            <a:pPr>
+              <a:spcAft>
+                <a:spcPts val="1200"/>
+              </a:spcAft>
+              <a:defRPr sz="1800">
+                <a:solidFill>
+                  <a:srgbClr val="333333"/>
+                </a:solidFill>
+              </a:defRPr>
+            </a:pPr>
+            <a:r>
+              <a:t>Accompagnement client et organisation de réunions</a:t>
+            </a:r>
+          </a:p>
+          <a:p>
+            <a:pPr>
+              <a:spcAft>
+                <a:spcPts val="1200"/>
+              </a:spcAft>
+              <a:defRPr sz="1800">
+                <a:solidFill>
+                  <a:srgbClr val="333333"/>
+                </a:solidFill>
+              </a:defRPr>
+            </a:pPr>
+            <a:r>
+              <a:t>Mission phare : Marketing d'influence avec Ayaa.lbns</a:t>
             </a:r>
           </a:p>
         </p:txBody>
@@ -8464,7 +8464,7 @@
               </a:defRPr>
             </a:pPr>
             <a:r>
-              <a:t>✨ Projet stratégique mené de A à Z</a:t>
+              <a:t>Projet stratégique mené de A à Z</a:t>
             </a:r>
           </a:p>
           <a:p>
@@ -8479,7 +8479,7 @@
               </a:defRPr>
             </a:pPr>
             <a:r>
-              <a:t>🎯 De l'idée initiale à la signature du contrat</a:t>
+              <a:t>De l'idée initiale à la signature du contrat</a:t>
             </a:r>
           </a:p>
           <a:p>
@@ -8494,7 +8494,7 @@
               </a:defRPr>
             </a:pPr>
             <a:r>
-              <a:t>💼 Responsabilité : Prospection, négociation, coordination</a:t>
+              <a:t>Responsabilité : Prospection, négociation, coordination</a:t>
             </a:r>
           </a:p>
         </p:txBody>
@@ -8675,82 +8675,82 @@
               </a:defRPr>
             </a:pPr>
             <a:r>
-              <a:t>💡 Initiative personnelle : Proposition lors d'une réunion avec la direction</a:t>
-            </a:r>
-          </a:p>
-          <a:p>
-            <a:pPr>
-              <a:spcAft>
-                <a:spcPts val="1200"/>
-              </a:spcAft>
-              <a:defRPr sz="1800">
-                <a:solidFill>
-                  <a:srgbClr val="333333"/>
-                </a:solidFill>
-              </a:defRPr>
-            </a:pPr>
-            <a:r>
-              <a:t>❓ Problématique : Comment accroître rapidement la visibilité de Buroxia ?</a:t>
-            </a:r>
-          </a:p>
-          <a:p>
-            <a:pPr>
-              <a:spcAft>
-                <a:spcPts val="1200"/>
-              </a:spcAft>
-              <a:defRPr sz="1800">
-                <a:solidFill>
-                  <a:srgbClr val="333333"/>
-                </a:solidFill>
-              </a:defRPr>
-            </a:pPr>
-            <a:r>
-              <a:t>🎯 Stratégie : S'appuyer sur le marketing d'influence</a:t>
-            </a:r>
-          </a:p>
-          <a:p>
-            <a:pPr>
-              <a:spcAft>
-                <a:spcPts val="1200"/>
-              </a:spcAft>
-              <a:defRPr sz="1800">
-                <a:solidFill>
-                  <a:srgbClr val="333333"/>
-                </a:solidFill>
-              </a:defRPr>
-            </a:pPr>
-            <a:r>
-              <a:t>✅ Validation : La direction valide le projet et me confie la mission</a:t>
-            </a:r>
-          </a:p>
-          <a:p>
-            <a:pPr>
-              <a:spcAft>
-                <a:spcPts val="1200"/>
-              </a:spcAft>
-              <a:defRPr sz="1800">
-                <a:solidFill>
-                  <a:srgbClr val="333333"/>
-                </a:solidFill>
-              </a:defRPr>
-            </a:pPr>
-            <a:r>
-              <a:t>📋 Objectif : Identifier et conclure un partenariat avec une influenceuse</a:t>
-            </a:r>
-          </a:p>
-          <a:p>
-            <a:pPr>
-              <a:spcAft>
-                <a:spcPts val="1200"/>
-              </a:spcAft>
-              <a:defRPr sz="1800">
-                <a:solidFill>
-                  <a:srgbClr val="333333"/>
-                </a:solidFill>
-              </a:defRPr>
-            </a:pPr>
-            <a:r>
-              <a:t>🚀 Responsabilité : Porteur du projet du début à la fin</a:t>
+              <a:t>Initiative personnelle : Proposition lors d'une réunion avec la direction</a:t>
+            </a:r>
+          </a:p>
+          <a:p>
+            <a:pPr>
+              <a:spcAft>
+                <a:spcPts val="1200"/>
+              </a:spcAft>
+              <a:defRPr sz="1800">
+                <a:solidFill>
+                  <a:srgbClr val="333333"/>
+                </a:solidFill>
+              </a:defRPr>
+            </a:pPr>
+            <a:r>
+              <a:t>Problématique : Comment accroître rapidement la visibilité de Buroxia ?</a:t>
+            </a:r>
+          </a:p>
+          <a:p>
+            <a:pPr>
+              <a:spcAft>
+                <a:spcPts val="1200"/>
+              </a:spcAft>
+              <a:defRPr sz="1800">
+                <a:solidFill>
+                  <a:srgbClr val="333333"/>
+                </a:solidFill>
+              </a:defRPr>
+            </a:pPr>
+            <a:r>
+              <a:t>Stratégie : S'appuyer sur le marketing d'influence</a:t>
+            </a:r>
+          </a:p>
+          <a:p>
+            <a:pPr>
+              <a:spcAft>
+                <a:spcPts val="1200"/>
+              </a:spcAft>
+              <a:defRPr sz="1800">
+                <a:solidFill>
+                  <a:srgbClr val="333333"/>
+                </a:solidFill>
+              </a:defRPr>
+            </a:pPr>
+            <a:r>
+              <a:t>Validation : La direction valide le projet et me confie la mission</a:t>
+            </a:r>
+          </a:p>
+          <a:p>
+            <a:pPr>
+              <a:spcAft>
+                <a:spcPts val="1200"/>
+              </a:spcAft>
+              <a:defRPr sz="1800">
+                <a:solidFill>
+                  <a:srgbClr val="333333"/>
+                </a:solidFill>
+              </a:defRPr>
+            </a:pPr>
+            <a:r>
+              <a:t>Objectif : Identifier et conclure un partenariat avec une influenceuse</a:t>
+            </a:r>
+          </a:p>
+          <a:p>
+            <a:pPr>
+              <a:spcAft>
+                <a:spcPts val="1200"/>
+              </a:spcAft>
+              <a:defRPr sz="1800">
+                <a:solidFill>
+                  <a:srgbClr val="333333"/>
+                </a:solidFill>
+              </a:defRPr>
+            </a:pPr>
+            <a:r>
+              <a:t>Responsabilité : Porteur du projet du début à la fin</a:t>
             </a:r>
           </a:p>
         </p:txBody>
@@ -8931,82 +8931,82 @@
               </a:defRPr>
             </a:pPr>
             <a:r>
-              <a:t>🔍 Veille active sur Instagram et TikTok</a:t>
-            </a:r>
-          </a:p>
-          <a:p>
-            <a:pPr>
-              <a:spcAft>
-                <a:spcPts val="1200"/>
-              </a:spcAft>
-              <a:defRPr sz="1800">
-                <a:solidFill>
-                  <a:srgbClr val="333333"/>
-                </a:solidFill>
-              </a:defRPr>
-            </a:pPr>
-            <a:r>
-              <a:t>📊 Analyse : audience, ligne éditoriale, adéquation avec Buroxia</a:t>
-            </a:r>
-          </a:p>
-          <a:p>
-            <a:pPr>
-              <a:spcAft>
-                <a:spcPts val="1200"/>
-              </a:spcAft>
-              <a:defRPr sz="1800">
-                <a:solidFill>
-                  <a:srgbClr val="333333"/>
-                </a:solidFill>
-              </a:defRPr>
-            </a:pPr>
-            <a:r>
-              <a:t>📧 Démarche : Messages privés et e-mails de contact</a:t>
-            </a:r>
-          </a:p>
-          <a:p>
-            <a:pPr>
-              <a:spcAft>
-                <a:spcPts val="1200"/>
-              </a:spcAft>
-              <a:defRPr sz="1800">
-                <a:solidFill>
-                  <a:srgbClr val="333333"/>
-                </a:solidFill>
-              </a:defRPr>
-            </a:pPr>
-            <a:r>
-              <a:t>❌ Difficultés : Plusieurs refus, manque de notoriété de Buroxia</a:t>
-            </a:r>
-          </a:p>
-          <a:p>
-            <a:pPr>
-              <a:spcAft>
-                <a:spcPts val="1200"/>
-              </a:spcAft>
-              <a:defRPr sz="1800">
-                <a:solidFill>
-                  <a:srgbClr val="333333"/>
-                </a:solidFill>
-              </a:defRPr>
-            </a:pPr>
-            <a:r>
-              <a:t>💪 Persévérance : Poursuite de la veille malgré les obstacles</a:t>
-            </a:r>
-          </a:p>
-          <a:p>
-            <a:pPr>
-              <a:spcAft>
-                <a:spcPts val="1200"/>
-              </a:spcAft>
-              <a:defRPr sz="1800">
-                <a:solidFill>
-                  <a:srgbClr val="333333"/>
-                </a:solidFill>
-              </a:defRPr>
-            </a:pPr>
-            <a:r>
-              <a:t>✨ Résultat : Identification d'une opportunité avec Ayaa.lbns</a:t>
+              <a:t>Veille active sur Instagram et TikTok</a:t>
+            </a:r>
+          </a:p>
+          <a:p>
+            <a:pPr>
+              <a:spcAft>
+                <a:spcPts val="1200"/>
+              </a:spcAft>
+              <a:defRPr sz="1800">
+                <a:solidFill>
+                  <a:srgbClr val="333333"/>
+                </a:solidFill>
+              </a:defRPr>
+            </a:pPr>
+            <a:r>
+              <a:t>Analyse : audience, ligne éditoriale, adéquation avec Buroxia</a:t>
+            </a:r>
+          </a:p>
+          <a:p>
+            <a:pPr>
+              <a:spcAft>
+                <a:spcPts val="1200"/>
+              </a:spcAft>
+              <a:defRPr sz="1800">
+                <a:solidFill>
+                  <a:srgbClr val="333333"/>
+                </a:solidFill>
+              </a:defRPr>
+            </a:pPr>
+            <a:r>
+              <a:t>Démarche : Messages privés et e-mails de contact</a:t>
+            </a:r>
+          </a:p>
+          <a:p>
+            <a:pPr>
+              <a:spcAft>
+                <a:spcPts val="1200"/>
+              </a:spcAft>
+              <a:defRPr sz="1800">
+                <a:solidFill>
+                  <a:srgbClr val="333333"/>
+                </a:solidFill>
+              </a:defRPr>
+            </a:pPr>
+            <a:r>
+              <a:t>Difficultés : Plusieurs refus, manque de notoriété de Buroxia</a:t>
+            </a:r>
+          </a:p>
+          <a:p>
+            <a:pPr>
+              <a:spcAft>
+                <a:spcPts val="1200"/>
+              </a:spcAft>
+              <a:defRPr sz="1800">
+                <a:solidFill>
+                  <a:srgbClr val="333333"/>
+                </a:solidFill>
+              </a:defRPr>
+            </a:pPr>
+            <a:r>
+              <a:t>Persévérance : Poursuite de la veille malgré les obstacles</a:t>
+            </a:r>
+          </a:p>
+          <a:p>
+            <a:pPr>
+              <a:spcAft>
+                <a:spcPts val="1200"/>
+              </a:spcAft>
+              <a:defRPr sz="1800">
+                <a:solidFill>
+                  <a:srgbClr val="333333"/>
+                </a:solidFill>
+              </a:defRPr>
+            </a:pPr>
+            <a:r>
+              <a:t>Résultat : Identification d'une opportunité avec Ayaa.lbns</a:t>
             </a:r>
           </a:p>
         </p:txBody>

</xml_diff>